<commit_message>
Add narrated capstone walkthrough captions and verified presentation artifacts
</commit_message>
<xml_diff>
--- a/docs/presentation/StockPilot-Capstone.pptx
+++ b/docs/presentation/StockPilot-Capstone.pptx
@@ -5693,7 +5693,7 @@
               </a:defRPr>
             </a:pPr>
             <a:r>
-              <a:t>RECEIVE → RESERVE</a:t>
+              <a:t>RECEIVE / RESERVE</a:t>
             </a:r>
           </a:p>
           <a:p>
@@ -5715,7 +5715,7 @@
               </a:defRPr>
             </a:pPr>
             <a:r>
-              <a:t>TRANSFER → REPLENISH</a:t>
+              <a:t>TRANSFER / REPLENISH</a:t>
             </a:r>
           </a:p>
         </p:txBody>
@@ -6961,7 +6961,7 @@
               </a:defRPr>
             </a:pPr>
             <a:r>
-              <a:t>Report cache unavailable → explicit report error. Live dashboard → database-backed request.</a:t>
+              <a:t>Report cache unavailable &gt; explicit report error. Live dashboard &gt; database-backed request.</a:t>
             </a:r>
           </a:p>
         </p:txBody>
@@ -10137,7 +10137,7 @@
               </a:defRPr>
             </a:pPr>
             <a:r>
-              <a:t>Commit SHA → container image → Helm value → deployed revision</a:t>
+              <a:t>Commit SHA &gt; container image &gt; Helm value &gt; deployed revision</a:t>
             </a:r>
           </a:p>
         </p:txBody>
@@ -12685,7 +12685,7 @@
               </a:defRPr>
             </a:pPr>
             <a:r>
-              <a:t>PROMETHEUS → GRAFANA</a:t>
+              <a:t>PROMETHEUS &gt; GRAFANA</a:t>
             </a:r>
           </a:p>
         </p:txBody>
@@ -12929,7 +12929,7 @@
               </a:defRPr>
             </a:pPr>
             <a:r>
-              <a:t>GIT → ARGO CD</a:t>
+              <a:t>GIT &gt; ARGO CD</a:t>
             </a:r>
           </a:p>
         </p:txBody>
@@ -13688,7 +13688,7 @@
               </a:defRPr>
             </a:pPr>
             <a:r>
-              <a:t>Internet access and optional NAT</a:t>
+              <a:t>Default demo worker placement</a:t>
             </a:r>
           </a:p>
           <a:p>
@@ -13710,7 +13710,7 @@
               </a:defRPr>
             </a:pPr>
             <a:r>
-              <a:t>Explicit networking choices</a:t>
+              <a:t>Public IPs; NAT is optional</a:t>
             </a:r>
           </a:p>
         </p:txBody>
@@ -13847,7 +13847,7 @@
               </a:defRPr>
             </a:pPr>
             <a:r>
-              <a:t>EKS managed worker nodes</a:t>
+              <a:t>Workers here with NAT enabled</a:t>
             </a:r>
           </a:p>
           <a:p>
@@ -13869,7 +13869,7 @@
               </a:defRPr>
             </a:pPr>
             <a:r>
-              <a:t>Encrypted persistent storage</a:t>
+              <a:t>Private subnets remain defined</a:t>
             </a:r>
           </a:p>
         </p:txBody>
@@ -13914,7 +13914,7 @@
               </a:defRPr>
             </a:pPr>
             <a:r>
-              <a:t>Plan → review → apply → verify → capture → destroy</a:t>
+              <a:t>Plan &gt; review &gt; apply &gt; verify &gt; capture &gt; destroy</a:t>
             </a:r>
           </a:p>
         </p:txBody>
@@ -14650,7 +14650,7 @@
               </a:defRPr>
             </a:pPr>
             <a:r>
-              <a:t>36 passed · 1 skipped</a:t>
+              <a:t>40 passed · 1 skipped</a:t>
             </a:r>
           </a:p>
         </p:txBody>
@@ -14830,7 +14830,7 @@
               </a:defRPr>
             </a:pPr>
             <a:r>
-              <a:t>TypeScript + build passed</a:t>
+              <a:t>13 tests + build passed</a:t>
             </a:r>
           </a:p>
         </p:txBody>
@@ -14875,7 +14875,7 @@
               </a:defRPr>
             </a:pPr>
             <a:r>
-              <a:t>Production JS 189.83 kB / gzip 57.70 kB</a:t>
+              <a:t>Component tests; browser capture pending</a:t>
             </a:r>
           </a:p>
         </p:txBody>
@@ -25068,7 +25068,7 @@
               </a:defRPr>
             </a:pPr>
             <a:r>
-              <a:t>140 total → 140 total</a:t>
+              <a:t>140 total &gt; 140 total</a:t>
             </a:r>
           </a:p>
         </p:txBody>
@@ -25158,7 +25158,7 @@
               </a:defRPr>
             </a:pPr>
             <a:r>
-              <a:t>Validate → lock product → check available → update both balances → append movement → commit</a:t>
+              <a:t>Validate &gt; lock product &gt; check available &gt; update both balances &gt; append movement &gt; commit</a:t>
             </a:r>
           </a:p>
         </p:txBody>

</xml_diff>

<commit_message>
Focus documentation and closing presentation on StockPilot workflows
</commit_message>
<xml_diff>
--- a/docs/presentation/StockPilot-Capstone.pptx
+++ b/docs/presentation/StockPilot-Capstone.pptx
@@ -1203,13 +1203,13 @@
           <a:lstStyle/>
           <a:p>
             <a:r>
-              <a:t>For the live presentation, start with the dashboard and catalogue. Receive stock, transfer it, reserve units, then demonstrate release and fulfilment. Create a purchase order and receive it to close the procurement loop. Next, show the checks, container deployment, persistent data, monitoring and GitOps evidence. The remaining environment-dependent captures are listed in the runbook. Chhavi Ahlawat's OpsPulse repository informed the organization of evidence and presentation material; the StockPilot domain, implementation and diagrams are original. Thank you for exploring how product rules and delivery engineering work together.</a:t>
+              <a:t>For the live presentation, start with the dashboard and catalogue. Receive stock, transfer it, reserve units, then demonstrate release and fulfilment. Create a purchase order and receive it to close the procurement loop. Next, show the checks, container deployment, persistent data, monitoring and GitOps evidence. The remaining environment-dependent captures are listed in the runbook. Thank you for exploring how product rules and delivery engineering work together.</a:t>
             </a:r>
           </a:p>
           <a:p/>
           <a:p>
             <a:r>
-              <a:t>Source / provenance: demo/RUNBOOK.md; docs/operations-guide.md; https://github.com/Chhavi07-arch/OpsPulse-devops-platform</a:t>
+              <a:t>Source / provenance: demo/RUNBOOK.md; docs/operations-guide.md</a:t>
             </a:r>
           </a:p>
         </p:txBody>
@@ -16368,7 +16368,7 @@
               </a:defRPr>
             </a:pPr>
             <a:r>
-              <a:t>Reference: Chhavi Ahlawat's OpsPulse for evidence organization; original StockPilot application and visuals.</a:t>
+              <a:t>Use the runbook to demonstrate product workflows, delivery checks and operational recovery.</a:t>
             </a:r>
           </a:p>
         </p:txBody>

</xml_diff>